<commit_message>
LSA Geomorphology: 18 decks rewritten from the teacher's course support
Lessons 1-16 and Further Studies 1-2 rebuilt natively (v3n/lsageo_*.js):
definitions apart, one point per slide with its illustration, examples from
Garoua, the Benue, Mount Cameroon and Lake Nyos, facts checked (Nyos CO2 1986,
Gouache 2019, eruptions of Mount Cameroon), and short homework preparing the
next lesson. New diagrams in big_geo2.py. The overlay helper moves to sixth3.js.

Co-Authored-By: Claude Opus 5.5 <noreply@anthropic.com>
Claude-Session: https://claude.ai/code/session_0115LFSb2ktGLWPeVksFkSer
</commit_message>
<xml_diff>
--- a/lecons/LSA/Geomorphology/19_LSA_GEOMO_FS03_Relief_of_Cameroon.pptx
+++ b/lecons/LSA/Geomorphology/19_LSA_GEOMO_FS03_Relief_of_Cameroon.pptx
@@ -3459,7 +3459,7 @@
           <a:p>
             <a:r>
               <a:rPr lang="en-US" dirty="0"/>
-              <a:t>Before we start the new lesson, let us correct the homework I gave you at the end of Lesson 16: Coastal Processes and Features. The question was: On a map of Cameroon, find Mount Cameroon, the Adamawa Plateau and the Chad Plain. Take out your exercise books.</a:t>
+              <a:t>Before we start the new lesson, let us correct the homework I gave you at the end of Lesson 16: Coastal Processes and Features. The question was: Name the highest mountain of Cameroon. Take out your exercise books.</a:t>
             </a:r>
             <a:endParaRPr lang="en-US" dirty="0"/>
           </a:p>
@@ -4251,7 +4251,7 @@
           <a:p>
             <a:r>
               <a:rPr lang="en-US" dirty="0"/>
-              <a:t>For your homework: Revise the Geomorphology lessons. Draw and label a sketch map of the relief of Cameroon. We shall correct it at the beginning of our next lesson.</a:t>
+              <a:t>For your homework: Define soil. We shall correct it at the beginning of our next lesson.</a:t>
             </a:r>
             <a:endParaRPr lang="en-US" dirty="0"/>
           </a:p>
@@ -4427,7 +4427,7 @@
           <a:p>
             <a:r>
               <a:rPr lang="en-US" dirty="0"/>
-              <a:t>Here is a good answer. Mount Cameroon is on the south-west coast near Buea; the Adamawa Plateau is in the centre (around Ngaoundéré); the Chad Plain is in the far north near Lake Chad. Compare it with your own answer and correct your work in red.</a:t>
+              <a:t>Here is a good answer. Mount Cameroon (4,095 m). Compare it with your own answer and correct your work in red.</a:t>
             </a:r>
             <a:endParaRPr lang="en-US" dirty="0"/>
           </a:p>
@@ -13291,7 +13291,7 @@
               <a:buNone/>
             </a:pPr>
             <a:r>
-              <a:rPr lang="en-US" sz="4000" b="1" dirty="0">
+              <a:rPr lang="en-US" sz="3200" b="1" dirty="0">
                 <a:solidFill>
                   <a:srgbClr val="111111"/>
                 </a:solidFill>
@@ -13301,7 +13301,7 @@
               </a:rPr>
               <a:t>Topic: Denudational Processes on Slopes</a:t>
             </a:r>
-            <a:endParaRPr lang="en-US" sz="4000" dirty="0"/>
+            <a:endParaRPr lang="en-US" sz="3200" dirty="0"/>
           </a:p>
           <a:p>
             <a:pPr algn="l" indent="0" marL="0">
@@ -13311,7 +13311,7 @@
               <a:buNone/>
             </a:pPr>
             <a:r>
-              <a:rPr lang="en-US" sz="4000" b="1" dirty="0">
+              <a:rPr lang="en-US" sz="3200" b="1" dirty="0">
                 <a:solidFill>
                   <a:srgbClr val="111111"/>
                 </a:solidFill>
@@ -13321,7 +13321,7 @@
               </a:rPr>
               <a:t>Sub-topic: Erosion and Depositional Processes and Landforms</a:t>
             </a:r>
-            <a:endParaRPr lang="en-US" sz="4000" dirty="0"/>
+            <a:endParaRPr lang="en-US" sz="3200" dirty="0"/>
           </a:p>
           <a:p>
             <a:pPr algn="l" indent="0" marL="0">
@@ -13331,7 +13331,7 @@
               <a:buNone/>
             </a:pPr>
             <a:r>
-              <a:rPr lang="en-US" sz="4000" b="1" dirty="0">
+              <a:rPr lang="en-US" sz="3200" b="1" dirty="0">
                 <a:solidFill>
                   <a:srgbClr val="990011"/>
                 </a:solidFill>
@@ -13341,7 +13341,7 @@
               </a:rPr>
               <a:t>Further Study 3: Relief of Cameroon</a:t>
             </a:r>
-            <a:endParaRPr lang="en-US" sz="4000" dirty="0"/>
+            <a:endParaRPr lang="en-US" sz="3200" dirty="0"/>
           </a:p>
         </p:txBody>
       </p:sp>
@@ -15012,7 +15012,7 @@
                 <a:ea typeface="Times New Roman" pitchFamily="34" charset="-122"/>
                 <a:cs typeface="Times New Roman" pitchFamily="34" charset="-120"/>
               </a:rPr>
-              <a:t>On a map of Cameroon, find Mount Cameroon, the Adamawa Plateau and the Chad Plain.</a:t>
+              <a:t>Name the highest mountain of Cameroon.</a:t>
             </a:r>
             <a:endParaRPr lang="en-US" sz="4000" dirty="0"/>
           </a:p>
@@ -17157,7 +17157,7 @@
                 <a:ea typeface="Times New Roman" pitchFamily="34" charset="-122"/>
                 <a:cs typeface="Times New Roman" pitchFamily="34" charset="-120"/>
               </a:rPr>
-              <a:t>Revise the Geomorphology lessons. Draw and label a sketch map of the relief of Cameroon.</a:t>
+              <a:t>Define soil.</a:t>
             </a:r>
             <a:endParaRPr lang="en-US" sz="4000" dirty="0"/>
           </a:p>
@@ -17615,7 +17615,7 @@
                 <a:ea typeface="Times New Roman" pitchFamily="34" charset="-122"/>
                 <a:cs typeface="Times New Roman" pitchFamily="34" charset="-120"/>
               </a:rPr>
-              <a:t>Mount Cameroon is on the south-west coast near Buea; the Adamawa Plateau is in the centre (around Ngaoundéré); the Chad Plain is in the far north near Lake Chad.</a:t>
+              <a:t>Mount Cameroon (4,095 m).</a:t>
             </a:r>
             <a:endParaRPr lang="en-US" sz="4000" dirty="0"/>
           </a:p>
@@ -20040,7 +20040,7 @@
                           <a:ea typeface="Calibri" pitchFamily="34" charset="-122"/>
                           <a:cs typeface="Calibri" pitchFamily="34" charset="-120"/>
                         </a:rPr>
-                        <a:t>Revise the Geomorphology lessons. Draw and label a sketch map of the relief of Cameroon.</a:t>
+                        <a:t>Define soil.</a:t>
                       </a:r>
                       <a:endParaRPr lang="en-US" sz="1600" dirty="0">
                         <a:latin typeface="Calibri" charset="0"/>

</xml_diff>